<commit_message>
fix(home,about, data, pptx-docs): reupdate page home,about and portfolio data
</commit_message>
<xml_diff>
--- a/Project_Development_Portfolio_Haidar_v5_Master.pptx
+++ b/Project_Development_Portfolio_Haidar_v5_Master.pptx
@@ -3262,7 +3262,7 @@
                 <a:ea typeface="Segoe UI" pitchFamily="34" charset="-122"/>
                 <a:cs typeface="Segoe UI" pitchFamily="34" charset="-120"/>
               </a:rPr>
-              <a:t>Senior Full-Stack Software Engineer &amp; Dev Lead (Developer Leader) | Industry-Standard Adaptive Engineer with Practical AI Workflow &amp; Hardware Integration Experience</a:t>
+              <a:t>Senior Full-Stack Software Engineer &amp; Lead Project Management / Business Analyst | Industry-Standard Adaptive Engineer with Practical AI Workflow &amp; Hardware Integration Experience</a:t>
             </a:r>
             <a:endParaRPr lang="en-US" sz="1600" dirty="0"/>
           </a:p>
@@ -26225,7 +26225,7 @@
                 <a:ea typeface="Segoe UI" pitchFamily="34" charset="-122"/>
                 <a:cs typeface="Segoe UI" pitchFamily="34" charset="-120"/>
               </a:rPr>
-              <a:t>Available for Remote, Hybrid, or On-Site Senior Full-Stack Engineering &amp; Dev Lead (Developer Leader) Roles</a:t>
+              <a:t>Available for Remote, Hybrid, or On-Site Senior Full-Stack Engineering, Project Management &amp; Business Analyst Leadership Roles</a:t>
             </a:r>
             <a:endParaRPr lang="en-US" sz="1600" dirty="0"/>
           </a:p>

</xml_diff>